<commit_message>
fix(clase-12): mueve la clase al miercoles 23/09
La Clase 12 se dicto el miercoles 23 de septiembre de 08:30 a 10:50, no en el
bloque de recuperacion del martes 22. Ajusta la fecha, el horario y el bloque 4
del README y la portada del deck.

Co-Authored-By: Claude Opus 5.5 <noreply@anthropic.com>
Claude-Session: https://claude.ai/code/session_01G8ZMAoyjRuPjQDimMZxkaQ
</commit_message>
<xml_diff>
--- a/clases/semana-04/03/ppt/Clase-12-La-Pieza-Sola.pptx
+++ b/clases/semana-04/03/ppt/Clase-12-La-Pieza-Sola.pptx
@@ -5655,7 +5655,7 @@
                 <a:ea typeface="Aptos" pitchFamily="34" charset="-122"/>
                 <a:cs typeface="Aptos" pitchFamily="34" charset="-120"/>
               </a:rPr>
-              <a:t>Martes 22 de septiembre de 2026 · 11:00 – 13:15 · Laboratorio de Redes</a:t>
+              <a:t>Miércoles 23 de septiembre de 2026 · 08:30 – 10:50 · Laboratorio PC</a:t>
             </a:r>
             <a:endParaRPr lang="en-US" sz="1260" dirty="0"/>
           </a:p>
@@ -40374,7 +40374,7 @@
                 <a:ea typeface="Aptos" pitchFamily="34" charset="-122"/>
                 <a:cs typeface="Aptos" pitchFamily="34" charset="-120"/>
               </a:rPr>
-              <a:t>BLOQUE 4 DE 4 · 20 MINUTOS</a:t>
+              <a:t>BLOQUE 4 DE 4 · 25 MINUTOS</a:t>
             </a:r>
             <a:endParaRPr lang="en-US" sz="960" dirty="0"/>
           </a:p>
@@ -53780,7 +53780,7 @@
                 <a:ea typeface="Aptos" pitchFamily="34" charset="-122"/>
                 <a:cs typeface="Aptos" pitchFamily="34" charset="-120"/>
               </a:rPr>
-              <a:t>11:10</a:t>
+              <a:t>08:40</a:t>
             </a:r>
             <a:endParaRPr lang="en-US" sz="1120" dirty="0"/>
           </a:p>
@@ -53989,7 +53989,7 @@
                 <a:ea typeface="Aptos" pitchFamily="34" charset="-122"/>
                 <a:cs typeface="Aptos" pitchFamily="34" charset="-120"/>
               </a:rPr>
-              <a:t>11:40</a:t>
+              <a:t>09:10</a:t>
             </a:r>
             <a:endParaRPr lang="en-US" sz="1120" dirty="0"/>
           </a:p>
@@ -54198,7 +54198,7 @@
                 <a:ea typeface="Aptos" pitchFamily="34" charset="-122"/>
                 <a:cs typeface="Aptos" pitchFamily="34" charset="-120"/>
               </a:rPr>
-              <a:t>12:15</a:t>
+              <a:t>09:45</a:t>
             </a:r>
             <a:endParaRPr lang="en-US" sz="1120" dirty="0"/>
           </a:p>
@@ -54407,7 +54407,7 @@
                 <a:ea typeface="Aptos" pitchFamily="34" charset="-122"/>
                 <a:cs typeface="Aptos" pitchFamily="34" charset="-120"/>
               </a:rPr>
-              <a:t>12:45</a:t>
+              <a:t>10:15</a:t>
             </a:r>
             <a:endParaRPr lang="en-US" sz="1120" dirty="0"/>
           </a:p>
@@ -54552,7 +54552,7 @@
                 <a:ea typeface="Aptos" pitchFamily="34" charset="-122"/>
                 <a:cs typeface="Aptos" pitchFamily="34" charset="-120"/>
               </a:rPr>
-              <a:t>Pausa: 12:05 – 12:15 · Cierre: 13:05 – 13:15 · Corte de la Evaluación Parcial 2: viernes 25 de septiembre</a:t>
+              <a:t>Pausa: 09:35 – 09:45 · Cierre: 10:40 – 10:50 · Corte de la Evaluación Parcial 2: viernes 25 de septiembre</a:t>
             </a:r>
             <a:endParaRPr lang="en-US" sz="1200" dirty="0"/>
           </a:p>

</xml_diff>